<commit_message>
A521 C18 minor changes
</commit_message>
<xml_diff>
--- a/ACCTG_521/ACCTG521Class18_2025.pptx
+++ b/ACCTG_521/ACCTG521Class18_2025.pptx
@@ -242,7 +242,7 @@
 <file path=ppt/revisionInfo.xml><?xml version="1.0" encoding="utf-8"?>
 <p1510:revInfo xmlns:a="http://schemas.openxmlformats.org/drawingml/2006/main" xmlns:r="http://schemas.openxmlformats.org/officeDocument/2006/relationships" xmlns:p1510="http://schemas.microsoft.com/office/powerpoint/2015/10/main">
   <p1510:revLst>
-    <p1510:client id="{DF3D4316-1591-43F4-9E3D-72E2E784E54F}" v="1" dt="2025-11-25T18:07:36.605"/>
+    <p1510:client id="{DF3D4316-1591-43F4-9E3D-72E2E784E54F}" v="2" dt="2025-11-25T18:33:35.379"/>
   </p1510:revLst>
 </p1510:revInfo>
 </file>
@@ -251,8 +251,8 @@
 <pc:chgInfo xmlns:a="http://schemas.openxmlformats.org/drawingml/2006/main" xmlns:r="http://schemas.openxmlformats.org/officeDocument/2006/relationships" xmlns:ac="http://schemas.microsoft.com/office/drawing/2013/main/command" xmlns:pc="http://schemas.microsoft.com/office/powerpoint/2013/main/command">
   <pc:docChgLst>
     <pc:chgData name="Asher Curtis" userId="494c4f5b-6d11-415a-9d9e-829c1135aa91" providerId="ADAL" clId="{FDEDEEF3-7275-4161-A24C-7071BE30F9A7}"/>
-    <pc:docChg chg="modSld modNotesMaster modHandout">
-      <pc:chgData name="Asher Curtis" userId="494c4f5b-6d11-415a-9d9e-829c1135aa91" providerId="ADAL" clId="{FDEDEEF3-7275-4161-A24C-7071BE30F9A7}" dt="2025-11-25T18:08:43.458" v="2" actId="20577"/>
+    <pc:docChg chg="custSel modSld modNotesMaster modHandout">
+      <pc:chgData name="Asher Curtis" userId="494c4f5b-6d11-415a-9d9e-829c1135aa91" providerId="ADAL" clId="{FDEDEEF3-7275-4161-A24C-7071BE30F9A7}" dt="2025-11-25T18:34:02.241" v="52" actId="207"/>
       <pc:docMkLst>
         <pc:docMk/>
       </pc:docMkLst>
@@ -268,6 +268,36 @@
             <pc:docMk/>
             <pc:sldMk cId="384289130" sldId="495"/>
             <ac:spMk id="9" creationId="{B2773AAD-913F-4F7D-B76C-297F2718F473}"/>
+          </ac:spMkLst>
+        </pc:spChg>
+      </pc:sldChg>
+      <pc:sldChg chg="delSp mod">
+        <pc:chgData name="Asher Curtis" userId="494c4f5b-6d11-415a-9d9e-829c1135aa91" providerId="ADAL" clId="{FDEDEEF3-7275-4161-A24C-7071BE30F9A7}" dt="2025-11-25T18:33:22.155" v="3" actId="478"/>
+        <pc:sldMkLst>
+          <pc:docMk/>
+          <pc:sldMk cId="1633124366" sldId="733"/>
+        </pc:sldMkLst>
+        <pc:spChg chg="del">
+          <ac:chgData name="Asher Curtis" userId="494c4f5b-6d11-415a-9d9e-829c1135aa91" providerId="ADAL" clId="{FDEDEEF3-7275-4161-A24C-7071BE30F9A7}" dt="2025-11-25T18:33:22.155" v="3" actId="478"/>
+          <ac:spMkLst>
+            <pc:docMk/>
+            <pc:sldMk cId="1633124366" sldId="733"/>
+            <ac:spMk id="23" creationId="{ED0CB7E7-AECA-40AE-AF51-28A35B3BCC8C}"/>
+          </ac:spMkLst>
+        </pc:spChg>
+      </pc:sldChg>
+      <pc:sldChg chg="addSp modSp mod">
+        <pc:chgData name="Asher Curtis" userId="494c4f5b-6d11-415a-9d9e-829c1135aa91" providerId="ADAL" clId="{FDEDEEF3-7275-4161-A24C-7071BE30F9A7}" dt="2025-11-25T18:34:02.241" v="52" actId="207"/>
+        <pc:sldMkLst>
+          <pc:docMk/>
+          <pc:sldMk cId="1964144993" sldId="2009"/>
+        </pc:sldMkLst>
+        <pc:spChg chg="add mod">
+          <ac:chgData name="Asher Curtis" userId="494c4f5b-6d11-415a-9d9e-829c1135aa91" providerId="ADAL" clId="{FDEDEEF3-7275-4161-A24C-7071BE30F9A7}" dt="2025-11-25T18:34:02.241" v="52" actId="207"/>
+          <ac:spMkLst>
+            <pc:docMk/>
+            <pc:sldMk cId="1964144993" sldId="2009"/>
+            <ac:spMk id="4" creationId="{4051AC39-721C-07A2-9E15-1515F9BED1B0}"/>
           </ac:spMkLst>
         </pc:spChg>
       </pc:sldChg>
@@ -6305,6 +6335,46 @@
           </a:p>
         </p:txBody>
       </p:sp>
+      <p:sp>
+        <p:nvSpPr>
+          <p:cNvPr id="4" name="TextBox 3">
+            <a:extLst>
+              <a:ext uri="{FF2B5EF4-FFF2-40B4-BE49-F238E27FC236}">
+                <a16:creationId xmlns:a16="http://schemas.microsoft.com/office/drawing/2014/main" id="{4051AC39-721C-07A2-9E15-1515F9BED1B0}"/>
+              </a:ext>
+            </a:extLst>
+          </p:cNvPr>
+          <p:cNvSpPr txBox="1"/>
+          <p:nvPr/>
+        </p:nvSpPr>
+        <p:spPr>
+          <a:xfrm>
+            <a:off x="4993294" y="4567213"/>
+            <a:ext cx="4187621" cy="369332"/>
+          </a:xfrm>
+          <a:prstGeom prst="rect">
+            <a:avLst/>
+          </a:prstGeom>
+          <a:noFill/>
+        </p:spPr>
+        <p:txBody>
+          <a:bodyPr wrap="none" rtlCol="0">
+            <a:spAutoFit/>
+          </a:bodyPr>
+          <a:lstStyle/>
+          <a:p>
+            <a:r>
+              <a:rPr lang="en-US" dirty="0">
+                <a:solidFill>
+                  <a:schemeClr val="tx2"/>
+                </a:solidFill>
+                <a:latin typeface="+mn-lt"/>
+              </a:rPr>
+              <a:t>**See example memo template (optional).</a:t>
+            </a:r>
+          </a:p>
+        </p:txBody>
+      </p:sp>
     </p:spTree>
     <p:extLst>
       <p:ext uri="{BB962C8B-B14F-4D97-AF65-F5344CB8AC3E}">
@@ -17075,54 +17145,6 @@
           </a:prstGeom>
         </p:spPr>
       </p:pic>
-      <p:sp>
-        <p:nvSpPr>
-          <p:cNvPr id="23" name="TextBox 22">
-            <a:extLst>
-              <a:ext uri="{FF2B5EF4-FFF2-40B4-BE49-F238E27FC236}">
-                <a16:creationId xmlns:a16="http://schemas.microsoft.com/office/drawing/2014/main" id="{ED0CB7E7-AECA-40AE-AF51-28A35B3BCC8C}"/>
-              </a:ext>
-            </a:extLst>
-          </p:cNvPr>
-          <p:cNvSpPr txBox="1"/>
-          <p:nvPr/>
-        </p:nvSpPr>
-        <p:spPr>
-          <a:xfrm>
-            <a:off x="3534384" y="5328612"/>
-            <a:ext cx="3560323" cy="230832"/>
-          </a:xfrm>
-          <a:prstGeom prst="rect">
-            <a:avLst/>
-          </a:prstGeom>
-          <a:noFill/>
-        </p:spPr>
-        <p:txBody>
-          <a:bodyPr wrap="square" rtlCol="0">
-            <a:spAutoFit/>
-          </a:bodyPr>
-          <a:lstStyle/>
-          <a:p>
-            <a:r>
-              <a:rPr lang="en-US" sz="900">
-                <a:hlinkClick r:id="rId5" tooltip="https://superuser.com/questions/1262987/how-can-i-see-if-a-login-failed-in-the-office-365-audit-log"/>
-              </a:rPr>
-              <a:t>This Photo</a:t>
-            </a:r>
-            <a:r>
-              <a:rPr lang="en-US" sz="900"/>
-              <a:t> by Unknown Author is licensed under </a:t>
-            </a:r>
-            <a:r>
-              <a:rPr lang="en-US" sz="900">
-                <a:hlinkClick r:id="rId6" tooltip="https://creativecommons.org/licenses/by-sa/3.0/"/>
-              </a:rPr>
-              <a:t>CC BY-SA</a:t>
-            </a:r>
-            <a:endParaRPr lang="en-US" sz="900"/>
-          </a:p>
-        </p:txBody>
-      </p:sp>
     </p:spTree>
     <p:extLst>
       <p:ext uri="{BB962C8B-B14F-4D97-AF65-F5344CB8AC3E}">

</xml_diff>